<commit_message>
Adicionando slides em pdf
</commit_message>
<xml_diff>
--- a/curso-python-ciencia-dados-main/modulo-4/slides/Consolidação e Qualidade - Entrega 3.pptx
+++ b/curso-python-ciencia-dados-main/modulo-4/slides/Consolidação e Qualidade - Entrega 3.pptx
@@ -75,7 +75,17 @@
                 <a:uFillTx/>
                 <a:latin typeface="Calibri"/>
               </a:rPr>
-              <a:t>Click to move the slide</a:t>
+              <a:t>Click to move </a:t>
+            </a:r>
+            <a:r>
+              <a:rPr b="0" lang="pt-BR" sz="1800" strike="noStrike" u="none">
+                <a:solidFill>
+                  <a:schemeClr val="dk1"/>
+                </a:solidFill>
+                <a:uFillTx/>
+                <a:latin typeface="Calibri"/>
+              </a:rPr>
+              <a:t>the slide</a:t>
             </a:r>
             <a:endParaRPr b="0" lang="pt-BR" sz="1800" strike="noStrike" u="none">
               <a:solidFill>
@@ -358,7 +368,7 @@
             <a:pPr indent="0" algn="r">
               <a:buNone/>
             </a:pPr>
-            <a:fld id="{0C74E0AA-8B12-4678-99E5-2EE57199C123}" type="slidenum">
+            <a:fld id="{F61EC74D-3148-44DF-ABE1-29E60BDC072E}" type="slidenum">
               <a:rPr b="0" lang="pt-BR" sz="1400" strike="noStrike" u="none">
                 <a:solidFill>
                   <a:srgbClr val="000000"/>
@@ -515,7 +525,7 @@
               </a:lnSpc>
               <a:buNone/>
             </a:pPr>
-            <a:fld id="{10F28D05-DADA-42D0-98E5-84DB3C33076A}" type="slidenum">
+            <a:fld id="{A9486FA1-21B5-4F2D-88D2-751312C9B30A}" type="slidenum">
               <a:rPr b="0" lang="en-US" sz="1200" strike="noStrike" u="none">
                 <a:solidFill>
                   <a:schemeClr val="dk1"/>
@@ -672,7 +682,7 @@
               </a:lnSpc>
               <a:buNone/>
             </a:pPr>
-            <a:fld id="{53AB9EDE-94C7-479C-AB2B-5900D5F1EE9A}" type="slidenum">
+            <a:fld id="{7C6BF456-5911-4720-A4C7-3A65B7A4DFA7}" type="slidenum">
               <a:rPr b="0" lang="en-US" sz="1200" strike="noStrike" u="none">
                 <a:solidFill>
                   <a:schemeClr val="dk1"/>
@@ -829,7 +839,7 @@
               </a:lnSpc>
               <a:buNone/>
             </a:pPr>
-            <a:fld id="{3AB266BD-B3B7-4C26-BDEC-01C00DF48314}" type="slidenum">
+            <a:fld id="{564261DB-20B4-4A50-9294-142064CBF92E}" type="slidenum">
               <a:rPr b="0" lang="en-US" sz="1200" strike="noStrike" u="none">
                 <a:solidFill>
                   <a:schemeClr val="dk1"/>
@@ -986,7 +996,7 @@
               </a:lnSpc>
               <a:buNone/>
             </a:pPr>
-            <a:fld id="{E40A94BF-49B9-4667-BABA-BB61553C6713}" type="slidenum">
+            <a:fld id="{C5782913-58EF-4F12-A102-516EE1FDF9B8}" type="slidenum">
               <a:rPr b="0" lang="en-US" sz="1200" strike="noStrike" u="none">
                 <a:solidFill>
                   <a:schemeClr val="dk1"/>
@@ -1143,7 +1153,7 @@
               </a:lnSpc>
               <a:buNone/>
             </a:pPr>
-            <a:fld id="{D7619A3F-DE9E-4B8D-A52C-B2A9054C9FC8}" type="slidenum">
+            <a:fld id="{ED745DDB-9F57-4BA2-9067-39BB55E02644}" type="slidenum">
               <a:rPr b="0" lang="en-US" sz="1200" strike="noStrike" u="none">
                 <a:solidFill>
                   <a:schemeClr val="dk1"/>
@@ -1300,7 +1310,7 @@
               </a:lnSpc>
               <a:buNone/>
             </a:pPr>
-            <a:fld id="{E6083858-7960-4900-8E97-60026BC4AF0C}" type="slidenum">
+            <a:fld id="{C9D4EF97-2A2D-4009-A8C2-327B72C69DF0}" type="slidenum">
               <a:rPr b="0" lang="en-US" sz="1200" strike="noStrike" u="none">
                 <a:solidFill>
                   <a:schemeClr val="dk1"/>
@@ -1457,7 +1467,7 @@
               </a:lnSpc>
               <a:buNone/>
             </a:pPr>
-            <a:fld id="{6D212507-DD57-49C8-9A3B-7758B8E95A93}" type="slidenum">
+            <a:fld id="{A35517E1-C569-4592-8496-F7635E14BA98}" type="slidenum">
               <a:rPr b="0" lang="en-US" sz="1200" strike="noStrike" u="none">
                 <a:solidFill>
                   <a:schemeClr val="dk1"/>
@@ -1614,7 +1624,7 @@
               </a:lnSpc>
               <a:buNone/>
             </a:pPr>
-            <a:fld id="{C85D4F07-7512-4BBF-879F-C528E538CBE1}" type="slidenum">
+            <a:fld id="{C67BAC40-13B7-423E-B899-1D53CE052B3C}" type="slidenum">
               <a:rPr b="0" lang="en-US" sz="1200" strike="noStrike" u="none">
                 <a:solidFill>
                   <a:schemeClr val="dk1"/>
@@ -1725,7 +1735,17 @@
                 <a:uFillTx/>
                 <a:latin typeface="Calibri"/>
               </a:rPr>
-              <a:t>Click to edit the title text format</a:t>
+              <a:t>Click to edit the title text </a:t>
+            </a:r>
+            <a:r>
+              <a:rPr b="0" lang="pt-BR" sz="1800" strike="noStrike" u="none">
+                <a:solidFill>
+                  <a:schemeClr val="dk1"/>
+                </a:solidFill>
+                <a:uFillTx/>
+                <a:latin typeface="Calibri"/>
+              </a:rPr>
+              <a:t>format</a:t>
             </a:r>
             <a:endParaRPr b="0" lang="pt-BR" sz="1800" strike="noStrike" u="none">
               <a:solidFill>
@@ -16273,7 +16293,7 @@
                 <a:latin typeface="Calibri"/>
                 <a:ea typeface="Calibri"/>
               </a:rPr>
-              <a:t>Equipe E  |  T326 - Ciência de Dados  |  UNIFOR</a:t>
+              <a:t>Equipe G  |  T326 - Ciência de Dados  |  UNIFOR</a:t>
             </a:r>
             <a:endParaRPr b="0" lang="pt-BR" sz="1300" strike="noStrike" u="none">
               <a:solidFill>

</xml_diff>